<commit_message>
docs: correct live governance-check count to 32/32 (verified live in ENFORCE) + regenerate decks/guides
</commit_message>
<xml_diff>
--- a/docs/PV-AgentCore-Customer.pptx
+++ b/docs/PV-AgentCore-Customer.pptx
@@ -2424,7 +2424,7 @@
                 <a:ea typeface="Calibri" pitchFamily="34" charset="-122"/>
                 <a:cs typeface="Calibri" pitchFamily="34" charset="-120"/>
               </a:rPr>
-              <a:t>Walk your safety, quality, privacy, and security teams through the architecture and the live 30-check proof.</a:t>
+              <a:t>Walk your safety, quality, privacy, and security teams through the architecture and the live 32-check proof.</a:t>
             </a:r>
             <a:endParaRPr lang="en-US" sz="1230" dirty="0"/>
           </a:p>
@@ -8946,7 +8946,7 @@
                 <a:ea typeface="Cambria" pitchFamily="34" charset="-122"/>
                 <a:cs typeface="Cambria" pitchFamily="34" charset="-120"/>
               </a:rPr>
-              <a:t>30/30</a:t>
+              <a:t>32/32</a:t>
             </a:r>
             <a:endParaRPr lang="en-US" sz="3200" dirty="0"/>
           </a:p>

</xml_diff>